<commit_message>
Update project identity: Waqar Rauf Butt, PHDAIF25M003, Advance Generative Model, Dr. Muhammad Farooq
- README, project spec, research report headers updated
- PDF report cover now shows student name, roll no, supervisor
- Presentation title slide and footer updated with correct details
- All Co-Authored-By references already removed in prior commit
</commit_message>
<xml_diff>
--- a/slides/presentation.pptx
+++ b/slides/presentation.pptx
@@ -3161,7 +3161,7 @@
         </p:nvSpPr>
         <p:spPr>
           <a:xfrm>
-            <a:off x="457200" y="914400"/>
+            <a:off x="457200" y="777240"/>
             <a:ext cx="8046720" cy="1828800"/>
           </a:xfrm>
           <a:prstGeom prst="rect">
@@ -3197,8 +3197,8 @@
         </p:nvSpPr>
         <p:spPr>
           <a:xfrm>
-            <a:off x="457200" y="2834640"/>
-            <a:ext cx="8046720" cy="457200"/>
+            <a:off x="457200" y="2697480"/>
+            <a:ext cx="8046720" cy="384048"/>
           </a:xfrm>
           <a:prstGeom prst="rect">
             <a:avLst/>
@@ -3213,13 +3213,13 @@
           <a:p>
             <a:pPr algn="l"/>
             <a:r>
-              <a:rPr sz="1600" b="0" i="0">
-                <a:solidFill>
-                  <a:srgbClr val="CADCFC"/>
-                </a:solidFill>
-                <a:latin typeface="Calibri"/>
-              </a:rPr>
-              <a:t>CAP6412 – Advanced Computer Vision  |  Spring 2025</a:t>
+              <a:rPr sz="1500" b="1" i="0">
+                <a:solidFill>
+                  <a:srgbClr val="F5C518"/>
+                </a:solidFill>
+                <a:latin typeface="Calibri"/>
+              </a:rPr>
+              <a:t>Advance Generative Model</a:t>
             </a:r>
           </a:p>
         </p:txBody>
@@ -3232,8 +3232,8 @@
         </p:nvSpPr>
         <p:spPr>
           <a:xfrm>
-            <a:off x="457200" y="3291840"/>
-            <a:ext cx="8046720" cy="365760"/>
+            <a:off x="457200" y="3127248"/>
+            <a:ext cx="1280160" cy="292608"/>
           </a:xfrm>
           <a:prstGeom prst="rect">
             <a:avLst/>
@@ -3248,13 +3248,13 @@
           <a:p>
             <a:pPr algn="l"/>
             <a:r>
-              <a:rPr sz="1400" b="0" i="0">
+              <a:rPr sz="1200" b="1" i="0">
                 <a:solidFill>
                   <a:srgbClr val="CADCFC"/>
                 </a:solidFill>
                 <a:latin typeface="Calibri"/>
               </a:rPr>
-              <a:t>UCF CRCV  |  Dr. Mubarak Shah</a:t>
+              <a:t>Student :</a:t>
             </a:r>
           </a:p>
         </p:txBody>
@@ -3267,8 +3267,183 @@
         </p:nvSpPr>
         <p:spPr>
           <a:xfrm>
-            <a:off x="457200" y="4572000"/>
-            <a:ext cx="8229600" cy="365760"/>
+            <a:off x="1783080" y="3127248"/>
+            <a:ext cx="5486400" cy="292608"/>
+          </a:xfrm>
+          <a:prstGeom prst="rect">
+            <a:avLst/>
+          </a:prstGeom>
+          <a:noFill/>
+        </p:spPr>
+        <p:txBody>
+          <a:bodyPr wrap="square">
+            <a:spAutoFit/>
+          </a:bodyPr>
+          <a:lstStyle/>
+          <a:p>
+            <a:pPr algn="l"/>
+            <a:r>
+              <a:rPr sz="1200" b="0" i="0">
+                <a:solidFill>
+                  <a:srgbClr val="FFFFFF"/>
+                </a:solidFill>
+                <a:latin typeface="Calibri"/>
+              </a:rPr>
+              <a:t>Waqar Rauf Butt</a:t>
+            </a:r>
+          </a:p>
+        </p:txBody>
+      </p:sp>
+      <p:sp>
+        <p:nvSpPr>
+          <p:cNvPr id="7" name="TextBox 6"/>
+          <p:cNvSpPr txBox="1"/>
+          <p:nvPr/>
+        </p:nvSpPr>
+        <p:spPr>
+          <a:xfrm>
+            <a:off x="457200" y="3429000"/>
+            <a:ext cx="1280160" cy="292608"/>
+          </a:xfrm>
+          <a:prstGeom prst="rect">
+            <a:avLst/>
+          </a:prstGeom>
+          <a:noFill/>
+        </p:spPr>
+        <p:txBody>
+          <a:bodyPr wrap="square">
+            <a:spAutoFit/>
+          </a:bodyPr>
+          <a:lstStyle/>
+          <a:p>
+            <a:pPr algn="l"/>
+            <a:r>
+              <a:rPr sz="1200" b="1" i="0">
+                <a:solidFill>
+                  <a:srgbClr val="CADCFC"/>
+                </a:solidFill>
+                <a:latin typeface="Calibri"/>
+              </a:rPr>
+              <a:t>Roll No :</a:t>
+            </a:r>
+          </a:p>
+        </p:txBody>
+      </p:sp>
+      <p:sp>
+        <p:nvSpPr>
+          <p:cNvPr id="8" name="TextBox 7"/>
+          <p:cNvSpPr txBox="1"/>
+          <p:nvPr/>
+        </p:nvSpPr>
+        <p:spPr>
+          <a:xfrm>
+            <a:off x="1783080" y="3429000"/>
+            <a:ext cx="5486400" cy="292608"/>
+          </a:xfrm>
+          <a:prstGeom prst="rect">
+            <a:avLst/>
+          </a:prstGeom>
+          <a:noFill/>
+        </p:spPr>
+        <p:txBody>
+          <a:bodyPr wrap="square">
+            <a:spAutoFit/>
+          </a:bodyPr>
+          <a:lstStyle/>
+          <a:p>
+            <a:pPr algn="l"/>
+            <a:r>
+              <a:rPr sz="1200" b="0" i="0">
+                <a:solidFill>
+                  <a:srgbClr val="FFFFFF"/>
+                </a:solidFill>
+                <a:latin typeface="Calibri"/>
+              </a:rPr>
+              <a:t>PHDAIF25M003</a:t>
+            </a:r>
+          </a:p>
+        </p:txBody>
+      </p:sp>
+      <p:sp>
+        <p:nvSpPr>
+          <p:cNvPr id="9" name="TextBox 8"/>
+          <p:cNvSpPr txBox="1"/>
+          <p:nvPr/>
+        </p:nvSpPr>
+        <p:spPr>
+          <a:xfrm>
+            <a:off x="457200" y="3730752"/>
+            <a:ext cx="1280160" cy="292608"/>
+          </a:xfrm>
+          <a:prstGeom prst="rect">
+            <a:avLst/>
+          </a:prstGeom>
+          <a:noFill/>
+        </p:spPr>
+        <p:txBody>
+          <a:bodyPr wrap="square">
+            <a:spAutoFit/>
+          </a:bodyPr>
+          <a:lstStyle/>
+          <a:p>
+            <a:pPr algn="l"/>
+            <a:r>
+              <a:rPr sz="1200" b="1" i="0">
+                <a:solidFill>
+                  <a:srgbClr val="CADCFC"/>
+                </a:solidFill>
+                <a:latin typeface="Calibri"/>
+              </a:rPr>
+              <a:t>Supervisor :</a:t>
+            </a:r>
+          </a:p>
+        </p:txBody>
+      </p:sp>
+      <p:sp>
+        <p:nvSpPr>
+          <p:cNvPr id="10" name="TextBox 9"/>
+          <p:cNvSpPr txBox="1"/>
+          <p:nvPr/>
+        </p:nvSpPr>
+        <p:spPr>
+          <a:xfrm>
+            <a:off x="1783080" y="3730752"/>
+            <a:ext cx="5486400" cy="292608"/>
+          </a:xfrm>
+          <a:prstGeom prst="rect">
+            <a:avLst/>
+          </a:prstGeom>
+          <a:noFill/>
+        </p:spPr>
+        <p:txBody>
+          <a:bodyPr wrap="square">
+            <a:spAutoFit/>
+          </a:bodyPr>
+          <a:lstStyle/>
+          <a:p>
+            <a:pPr algn="l"/>
+            <a:r>
+              <a:rPr sz="1200" b="0" i="0">
+                <a:solidFill>
+                  <a:srgbClr val="FFFFFF"/>
+                </a:solidFill>
+                <a:latin typeface="Calibri"/>
+              </a:rPr>
+              <a:t>Dr. Muhammad Farooq</a:t>
+            </a:r>
+          </a:p>
+        </p:txBody>
+      </p:sp>
+      <p:sp>
+        <p:nvSpPr>
+          <p:cNvPr id="11" name="TextBox 10"/>
+          <p:cNvSpPr txBox="1"/>
+          <p:nvPr/>
+        </p:nvSpPr>
+        <p:spPr>
+          <a:xfrm>
+            <a:off x="457200" y="4736592"/>
+            <a:ext cx="8229600" cy="274320"/>
           </a:xfrm>
           <a:prstGeom prst="rect">
             <a:avLst/>
@@ -7312,13 +7487,13 @@
           <a:p>
             <a:pPr algn="ctr"/>
             <a:r>
-              <a:rPr sz="1100" b="0" i="0">
+              <a:rPr sz="1000" b="0" i="0">
                 <a:solidFill>
                   <a:srgbClr val="FFFFFF"/>
                 </a:solidFill>
                 <a:latin typeface="Calibri"/>
               </a:rPr>
-              <a:t>github.com/waqarbutt58/BiasAudit-CAP6412   |   CAP6412 Spring 2025   |   UCF CRCV</a:t>
+              <a:t>github.com/waqarbutt58/BiasAudit-CAP6412   |   Advance Generative Model   |   Waqar Rauf Butt  |  PHDAIF25M003</a:t>
             </a:r>
           </a:p>
         </p:txBody>

</xml_diff>